<commit_message>
changes thorugh lecture 32
</commit_message>
<xml_diff>
--- a/Lecture_Slides/PH 123 Lecture 28.pptx
+++ b/Lecture_Slides/PH 123 Lecture 28.pptx
@@ -192,59 +192,100 @@
 </p:presentation>
 </file>
 
+<file path=ppt/revisionInfo.xml><?xml version="1.0" encoding="utf-8"?>
+<p1510:revInfo xmlns:a="http://schemas.openxmlformats.org/drawingml/2006/main" xmlns:r="http://schemas.openxmlformats.org/officeDocument/2006/relationships" xmlns:p1510="http://schemas.microsoft.com/office/powerpoint/2015/10/main">
+  <p1510:revLst>
+    <p1510:client id="{A5EC3263-46BD-4EEA-A665-0DA53B9817DD}" v="2" dt="2026-06-18T17:50:15.860"/>
+  </p1510:revLst>
+</p1510:revInfo>
+</file>
+
 <file path=ppt/changesInfos/changesInfo1.xml><?xml version="1.0" encoding="utf-8"?>
 <pc:chgInfo xmlns:a="http://schemas.openxmlformats.org/drawingml/2006/main" xmlns:r="http://schemas.openxmlformats.org/officeDocument/2006/relationships" xmlns:ac="http://schemas.microsoft.com/office/drawing/2013/main/command" xmlns:pc="http://schemas.microsoft.com/office/powerpoint/2013/main/command">
   <pc:docChgLst>
     <pc:chgData name="Lines, Todd" userId="afaf7c3a-e8aa-4568-882a-02ad8f9e19b0" providerId="ADAL" clId="{5FF5AC1B-ABA9-43D7-A1E3-2D92732CD6E2}"/>
     <pc:docChg chg="modSld">
-      <pc:chgData name="Lines, Todd" userId="afaf7c3a-e8aa-4568-882a-02ad8f9e19b0" providerId="ADAL" clId="{5FF5AC1B-ABA9-43D7-A1E3-2D92732CD6E2}" dt="2026-03-12T22:45:53.247" v="2" actId="1036"/>
+      <pc:chgData name="Lines, Todd" userId="afaf7c3a-e8aa-4568-882a-02ad8f9e19b0" providerId="ADAL" clId="{5FF5AC1B-ABA9-43D7-A1E3-2D92732CD6E2}" dt="2026-06-18T17:50:15.860" v="61" actId="14100"/>
       <pc:docMkLst>
         <pc:docMk/>
       </pc:docMkLst>
       <pc:sldChg chg="modSp mod">
-        <pc:chgData name="Lines, Todd" userId="afaf7c3a-e8aa-4568-882a-02ad8f9e19b0" providerId="ADAL" clId="{5FF5AC1B-ABA9-43D7-A1E3-2D92732CD6E2}" dt="2026-03-12T22:37:11.575" v="0" actId="20577"/>
+        <pc:chgData name="Lines, Todd" userId="afaf7c3a-e8aa-4568-882a-02ad8f9e19b0" providerId="ADAL" clId="{5FF5AC1B-ABA9-43D7-A1E3-2D92732CD6E2}" dt="2026-06-18T17:50:15.860" v="61" actId="14100"/>
         <pc:sldMkLst>
           <pc:docMk/>
-          <pc:sldMk cId="3132322049" sldId="306"/>
+          <pc:sldMk cId="0" sldId="338"/>
         </pc:sldMkLst>
-        <pc:spChg chg="mod">
-          <ac:chgData name="Lines, Todd" userId="afaf7c3a-e8aa-4568-882a-02ad8f9e19b0" providerId="ADAL" clId="{5FF5AC1B-ABA9-43D7-A1E3-2D92732CD6E2}" dt="2026-03-12T22:37:11.575" v="0" actId="20577"/>
-          <ac:spMkLst>
+        <pc:graphicFrameChg chg="mod">
+          <ac:chgData name="Lines, Todd" userId="afaf7c3a-e8aa-4568-882a-02ad8f9e19b0" providerId="ADAL" clId="{5FF5AC1B-ABA9-43D7-A1E3-2D92732CD6E2}" dt="2026-06-18T17:50:15.860" v="61" actId="14100"/>
+          <ac:graphicFrameMkLst>
             <pc:docMk/>
-            <pc:sldMk cId="3132322049" sldId="306"/>
-            <ac:spMk id="3" creationId="{0470406A-7789-9C25-64A2-FA8AA3F7F2E0}"/>
-          </ac:spMkLst>
-        </pc:spChg>
+            <pc:sldMk cId="0" sldId="338"/>
+            <ac:graphicFrameMk id="3077" creationId="{099DEB48-EFA8-96E0-18A1-C650B176A057}"/>
+          </ac:graphicFrameMkLst>
+        </pc:graphicFrameChg>
+        <pc:graphicFrameChg chg="mod">
+          <ac:chgData name="Lines, Todd" userId="afaf7c3a-e8aa-4568-882a-02ad8f9e19b0" providerId="ADAL" clId="{5FF5AC1B-ABA9-43D7-A1E3-2D92732CD6E2}" dt="2026-06-18T17:50:15.860" v="61" actId="14100"/>
+          <ac:graphicFrameMkLst>
+            <pc:docMk/>
+            <pc:sldMk cId="0" sldId="338"/>
+            <ac:graphicFrameMk id="3078" creationId="{C47D92B3-CC2E-9935-E1CD-AA17B3B35DDA}"/>
+          </ac:graphicFrameMkLst>
+        </pc:graphicFrameChg>
+        <pc:graphicFrameChg chg="mod">
+          <ac:chgData name="Lines, Todd" userId="afaf7c3a-e8aa-4568-882a-02ad8f9e19b0" providerId="ADAL" clId="{5FF5AC1B-ABA9-43D7-A1E3-2D92732CD6E2}" dt="2026-06-18T17:50:15.860" v="61" actId="14100"/>
+          <ac:graphicFrameMkLst>
+            <pc:docMk/>
+            <pc:sldMk cId="0" sldId="338"/>
+            <ac:graphicFrameMk id="3079" creationId="{32ABA143-3212-373A-D5BE-2D949ED03D2D}"/>
+          </ac:graphicFrameMkLst>
+        </pc:graphicFrameChg>
+        <pc:graphicFrameChg chg="mod">
+          <ac:chgData name="Lines, Todd" userId="afaf7c3a-e8aa-4568-882a-02ad8f9e19b0" providerId="ADAL" clId="{5FF5AC1B-ABA9-43D7-A1E3-2D92732CD6E2}" dt="2026-06-18T17:50:15.860" v="61" actId="14100"/>
+          <ac:graphicFrameMkLst>
+            <pc:docMk/>
+            <pc:sldMk cId="0" sldId="338"/>
+            <ac:graphicFrameMk id="3080" creationId="{DB91CBBC-AD96-F6A8-6738-FCB73C178C57}"/>
+          </ac:graphicFrameMkLst>
+        </pc:graphicFrameChg>
       </pc:sldChg>
       <pc:sldChg chg="modSp mod">
-        <pc:chgData name="Lines, Todd" userId="afaf7c3a-e8aa-4568-882a-02ad8f9e19b0" providerId="ADAL" clId="{5FF5AC1B-ABA9-43D7-A1E3-2D92732CD6E2}" dt="2026-03-12T22:45:47.770" v="1" actId="1036"/>
+        <pc:chgData name="Lines, Todd" userId="afaf7c3a-e8aa-4568-882a-02ad8f9e19b0" providerId="ADAL" clId="{5FF5AC1B-ABA9-43D7-A1E3-2D92732CD6E2}" dt="2026-06-18T17:49:56.055" v="56" actId="1035"/>
         <pc:sldMkLst>
           <pc:docMk/>
-          <pc:sldMk cId="0" sldId="312"/>
+          <pc:sldMk cId="0" sldId="339"/>
         </pc:sldMkLst>
-        <pc:spChg chg="mod">
-          <ac:chgData name="Lines, Todd" userId="afaf7c3a-e8aa-4568-882a-02ad8f9e19b0" providerId="ADAL" clId="{5FF5AC1B-ABA9-43D7-A1E3-2D92732CD6E2}" dt="2026-03-12T22:45:47.770" v="1" actId="1036"/>
-          <ac:spMkLst>
+        <pc:graphicFrameChg chg="mod">
+          <ac:chgData name="Lines, Todd" userId="afaf7c3a-e8aa-4568-882a-02ad8f9e19b0" providerId="ADAL" clId="{5FF5AC1B-ABA9-43D7-A1E3-2D92732CD6E2}" dt="2026-06-18T17:49:48.643" v="37" actId="1035"/>
+          <ac:graphicFrameMkLst>
             <pc:docMk/>
-            <pc:sldMk cId="0" sldId="312"/>
-            <ac:spMk id="27653" creationId="{FED2A12D-02E8-6CB9-AB2E-E70B4384A546}"/>
-          </ac:spMkLst>
-        </pc:spChg>
-      </pc:sldChg>
-      <pc:sldChg chg="modSp mod">
-        <pc:chgData name="Lines, Todd" userId="afaf7c3a-e8aa-4568-882a-02ad8f9e19b0" providerId="ADAL" clId="{5FF5AC1B-ABA9-43D7-A1E3-2D92732CD6E2}" dt="2026-03-12T22:45:53.247" v="2" actId="1036"/>
-        <pc:sldMkLst>
-          <pc:docMk/>
-          <pc:sldMk cId="0" sldId="313"/>
-        </pc:sldMkLst>
-        <pc:spChg chg="mod">
-          <ac:chgData name="Lines, Todd" userId="afaf7c3a-e8aa-4568-882a-02ad8f9e19b0" providerId="ADAL" clId="{5FF5AC1B-ABA9-43D7-A1E3-2D92732CD6E2}" dt="2026-03-12T22:45:53.247" v="2" actId="1036"/>
-          <ac:spMkLst>
+            <pc:sldMk cId="0" sldId="339"/>
+            <ac:graphicFrameMk id="4101" creationId="{26EA647A-F2F3-4DCF-685A-6A21192091C0}"/>
+          </ac:graphicFrameMkLst>
+        </pc:graphicFrameChg>
+        <pc:graphicFrameChg chg="mod">
+          <ac:chgData name="Lines, Todd" userId="afaf7c3a-e8aa-4568-882a-02ad8f9e19b0" providerId="ADAL" clId="{5FF5AC1B-ABA9-43D7-A1E3-2D92732CD6E2}" dt="2026-06-18T17:49:41.496" v="16" actId="1035"/>
+          <ac:graphicFrameMkLst>
             <pc:docMk/>
-            <pc:sldMk cId="0" sldId="313"/>
-            <ac:spMk id="28675" creationId="{A55195D3-9BF2-F6FC-4469-DABC837C968C}"/>
-          </ac:spMkLst>
-        </pc:spChg>
+            <pc:sldMk cId="0" sldId="339"/>
+            <ac:graphicFrameMk id="4102" creationId="{72832127-93A8-F8C0-E368-13D1DE7D30D7}"/>
+          </ac:graphicFrameMkLst>
+        </pc:graphicFrameChg>
+        <pc:graphicFrameChg chg="mod">
+          <ac:chgData name="Lines, Todd" userId="afaf7c3a-e8aa-4568-882a-02ad8f9e19b0" providerId="ADAL" clId="{5FF5AC1B-ABA9-43D7-A1E3-2D92732CD6E2}" dt="2026-06-18T17:49:56.055" v="56" actId="1035"/>
+          <ac:graphicFrameMkLst>
+            <pc:docMk/>
+            <pc:sldMk cId="0" sldId="339"/>
+            <ac:graphicFrameMk id="4103" creationId="{F95DB921-E241-E18D-F277-1305474F884A}"/>
+          </ac:graphicFrameMkLst>
+        </pc:graphicFrameChg>
+        <pc:graphicFrameChg chg="mod">
+          <ac:chgData name="Lines, Todd" userId="afaf7c3a-e8aa-4568-882a-02ad8f9e19b0" providerId="ADAL" clId="{5FF5AC1B-ABA9-43D7-A1E3-2D92732CD6E2}" dt="2026-06-18T17:49:32.951" v="4" actId="1076"/>
+          <ac:graphicFrameMkLst>
+            <pc:docMk/>
+            <pc:sldMk cId="0" sldId="339"/>
+            <ac:graphicFrameMk id="4104" creationId="{500B984E-FB25-57D6-41A1-A9D14096759E}"/>
+          </ac:graphicFrameMkLst>
+        </pc:graphicFrameChg>
       </pc:sldChg>
     </pc:docChg>
   </pc:docChgLst>
@@ -333,7 +374,7 @@
           <a:p>
             <a:fld id="{7A892725-F166-4357-BC82-0228278E9061}" type="datetimeFigureOut">
               <a:rPr lang="en-US" smtClean="0"/>
-              <a:t>3/12/2026</a:t>
+              <a:t>6/18/2026</a:t>
             </a:fld>
             <a:endParaRPr lang="en-US"/>
           </a:p>
@@ -1080,7 +1121,7 @@
             <a:fld id="{45D09D0E-00BC-47FC-BC29-A6800C1C6B52}" type="datetimeFigureOut">
               <a:rPr lang="en-US" smtClean="0"/>
               <a:pPr/>
-              <a:t>3/12/2026</a:t>
+              <a:t>6/18/2026</a:t>
             </a:fld>
             <a:endParaRPr lang="en-US"/>
           </a:p>
@@ -1245,7 +1286,7 @@
             <a:fld id="{45D09D0E-00BC-47FC-BC29-A6800C1C6B52}" type="datetimeFigureOut">
               <a:rPr lang="en-US" smtClean="0"/>
               <a:pPr/>
-              <a:t>3/12/2026</a:t>
+              <a:t>6/18/2026</a:t>
             </a:fld>
             <a:endParaRPr lang="en-US"/>
           </a:p>
@@ -1420,7 +1461,7 @@
             <a:fld id="{45D09D0E-00BC-47FC-BC29-A6800C1C6B52}" type="datetimeFigureOut">
               <a:rPr lang="en-US" smtClean="0"/>
               <a:pPr/>
-              <a:t>3/12/2026</a:t>
+              <a:t>6/18/2026</a:t>
             </a:fld>
             <a:endParaRPr lang="en-US"/>
           </a:p>
@@ -1839,7 +1880,7 @@
             <a:fld id="{45D09D0E-00BC-47FC-BC29-A6800C1C6B52}" type="datetimeFigureOut">
               <a:rPr lang="en-US" smtClean="0"/>
               <a:pPr/>
-              <a:t>3/12/2026</a:t>
+              <a:t>6/18/2026</a:t>
             </a:fld>
             <a:endParaRPr lang="en-US"/>
           </a:p>
@@ -2081,7 +2122,7 @@
             <a:fld id="{45D09D0E-00BC-47FC-BC29-A6800C1C6B52}" type="datetimeFigureOut">
               <a:rPr lang="en-US" smtClean="0"/>
               <a:pPr/>
-              <a:t>3/12/2026</a:t>
+              <a:t>6/18/2026</a:t>
             </a:fld>
             <a:endParaRPr lang="en-US"/>
           </a:p>
@@ -2363,7 +2404,7 @@
             <a:fld id="{45D09D0E-00BC-47FC-BC29-A6800C1C6B52}" type="datetimeFigureOut">
               <a:rPr lang="en-US" smtClean="0"/>
               <a:pPr/>
-              <a:t>3/12/2026</a:t>
+              <a:t>6/18/2026</a:t>
             </a:fld>
             <a:endParaRPr lang="en-US"/>
           </a:p>
@@ -2779,7 +2820,7 @@
             <a:fld id="{45D09D0E-00BC-47FC-BC29-A6800C1C6B52}" type="datetimeFigureOut">
               <a:rPr lang="en-US" smtClean="0"/>
               <a:pPr/>
-              <a:t>3/12/2026</a:t>
+              <a:t>6/18/2026</a:t>
             </a:fld>
             <a:endParaRPr lang="en-US"/>
           </a:p>
@@ -2893,7 +2934,7 @@
             <a:fld id="{45D09D0E-00BC-47FC-BC29-A6800C1C6B52}" type="datetimeFigureOut">
               <a:rPr lang="en-US" smtClean="0"/>
               <a:pPr/>
-              <a:t>3/12/2026</a:t>
+              <a:t>6/18/2026</a:t>
             </a:fld>
             <a:endParaRPr lang="en-US"/>
           </a:p>
@@ -2985,7 +3026,7 @@
             <a:fld id="{45D09D0E-00BC-47FC-BC29-A6800C1C6B52}" type="datetimeFigureOut">
               <a:rPr lang="en-US" smtClean="0"/>
               <a:pPr/>
-              <a:t>3/12/2026</a:t>
+              <a:t>6/18/2026</a:t>
             </a:fld>
             <a:endParaRPr lang="en-US"/>
           </a:p>
@@ -3257,7 +3298,7 @@
             <a:fld id="{45D09D0E-00BC-47FC-BC29-A6800C1C6B52}" type="datetimeFigureOut">
               <a:rPr lang="en-US" smtClean="0"/>
               <a:pPr/>
-              <a:t>3/12/2026</a:t>
+              <a:t>6/18/2026</a:t>
             </a:fld>
             <a:endParaRPr lang="en-US"/>
           </a:p>
@@ -3506,7 +3547,7 @@
             <a:fld id="{45D09D0E-00BC-47FC-BC29-A6800C1C6B52}" type="datetimeFigureOut">
               <a:rPr lang="en-US" smtClean="0"/>
               <a:pPr/>
-              <a:t>3/12/2026</a:t>
+              <a:t>6/18/2026</a:t>
             </a:fld>
             <a:endParaRPr lang="en-US"/>
           </a:p>
@@ -3714,7 +3755,7 @@
             <a:fld id="{45D09D0E-00BC-47FC-BC29-A6800C1C6B52}" type="datetimeFigureOut">
               <a:rPr lang="en-US" smtClean="0"/>
               <a:pPr/>
-              <a:t>3/12/2026</a:t>
+              <a:t>6/18/2026</a:t>
             </a:fld>
             <a:endParaRPr lang="en-US"/>
           </a:p>
@@ -17233,11 +17274,17 @@
           <p:cNvGraphicFramePr>
             <a:graphicFrameLocks noChangeAspect="1"/>
           </p:cNvGraphicFramePr>
-          <p:nvPr/>
+          <p:nvPr>
+            <p:extLst>
+              <p:ext uri="{D42A27DB-BD31-4B8C-83A1-F6EECF244321}">
+                <p14:modId xmlns:p14="http://schemas.microsoft.com/office/powerpoint/2010/main" val="3907732228"/>
+              </p:ext>
+            </p:extLst>
+          </p:nvPr>
         </p:nvGraphicFramePr>
         <p:xfrm>
-          <a:off x="1219200" y="4702175"/>
-          <a:ext cx="1887538" cy="974725"/>
+          <a:off x="1051631" y="3873501"/>
+          <a:ext cx="1589718" cy="820931"/>
         </p:xfrm>
         <a:graphic>
           <a:graphicData uri="http://schemas.openxmlformats.org/presentationml/2006/ole">
@@ -17279,8 +17326,8 @@
                     </p:blipFill>
                     <p:spPr bwMode="auto">
                       <a:xfrm>
-                        <a:off x="1219200" y="4702175"/>
-                        <a:ext cx="1887538" cy="974725"/>
+                        <a:off x="1051631" y="3873501"/>
+                        <a:ext cx="1589718" cy="820931"/>
                       </a:xfrm>
                       <a:prstGeom prst="rect">
                         <a:avLst/>
@@ -17289,25 +17336,6 @@
                       <a:ln>
                         <a:noFill/>
                       </a:ln>
-                      <a:extLst>
-                        <a:ext uri="{909E8E84-426E-40DD-AFC4-6F175D3DCCD1}">
-                          <a14:hiddenFill xmlns:a14="http://schemas.microsoft.com/office/drawing/2010/main">
-                            <a:solidFill>
-                              <a:srgbClr val="FFFFFF"/>
-                            </a:solidFill>
-                          </a14:hiddenFill>
-                        </a:ext>
-                        <a:ext uri="{91240B29-F687-4F45-9708-019B960494DF}">
-                          <a14:hiddenLine xmlns:a14="http://schemas.microsoft.com/office/drawing/2010/main" w="9525">
-                            <a:solidFill>
-                              <a:srgbClr val="000000"/>
-                            </a:solidFill>
-                            <a:miter lim="800000"/>
-                            <a:headEnd/>
-                            <a:tailEnd/>
-                          </a14:hiddenLine>
-                        </a:ext>
-                      </a:extLst>
                     </p:spPr>
                   </p:pic>
                 </p:oleObj>
@@ -17328,11 +17356,17 @@
           <p:cNvGraphicFramePr>
             <a:graphicFrameLocks noChangeAspect="1"/>
           </p:cNvGraphicFramePr>
-          <p:nvPr/>
+          <p:nvPr>
+            <p:extLst>
+              <p:ext uri="{D42A27DB-BD31-4B8C-83A1-F6EECF244321}">
+                <p14:modId xmlns:p14="http://schemas.microsoft.com/office/powerpoint/2010/main" val="2413260281"/>
+              </p:ext>
+            </p:extLst>
+          </p:nvPr>
         </p:nvGraphicFramePr>
         <p:xfrm>
-          <a:off x="1231900" y="3592513"/>
-          <a:ext cx="1728788" cy="974725"/>
+          <a:off x="1051631" y="2970212"/>
+          <a:ext cx="1456016" cy="820931"/>
         </p:xfrm>
         <a:graphic>
           <a:graphicData uri="http://schemas.openxmlformats.org/presentationml/2006/ole">
@@ -17374,8 +17408,8 @@
                     </p:blipFill>
                     <p:spPr bwMode="auto">
                       <a:xfrm>
-                        <a:off x="1231900" y="3592513"/>
-                        <a:ext cx="1728788" cy="974725"/>
+                        <a:off x="1051631" y="2970212"/>
+                        <a:ext cx="1456016" cy="820931"/>
                       </a:xfrm>
                       <a:prstGeom prst="rect">
                         <a:avLst/>
@@ -17384,25 +17418,6 @@
                       <a:ln>
                         <a:noFill/>
                       </a:ln>
-                      <a:extLst>
-                        <a:ext uri="{909E8E84-426E-40DD-AFC4-6F175D3DCCD1}">
-                          <a14:hiddenFill xmlns:a14="http://schemas.microsoft.com/office/drawing/2010/main">
-                            <a:solidFill>
-                              <a:srgbClr val="FFFFFF"/>
-                            </a:solidFill>
-                          </a14:hiddenFill>
-                        </a:ext>
-                        <a:ext uri="{91240B29-F687-4F45-9708-019B960494DF}">
-                          <a14:hiddenLine xmlns:a14="http://schemas.microsoft.com/office/drawing/2010/main" w="9525">
-                            <a:solidFill>
-                              <a:srgbClr val="000000"/>
-                            </a:solidFill>
-                            <a:miter lim="800000"/>
-                            <a:headEnd/>
-                            <a:tailEnd/>
-                          </a14:hiddenLine>
-                        </a:ext>
-                      </a:extLst>
                     </p:spPr>
                   </p:pic>
                 </p:oleObj>
@@ -17423,11 +17438,17 @@
           <p:cNvGraphicFramePr>
             <a:graphicFrameLocks noChangeAspect="1"/>
           </p:cNvGraphicFramePr>
-          <p:nvPr/>
+          <p:nvPr>
+            <p:extLst>
+              <p:ext uri="{D42A27DB-BD31-4B8C-83A1-F6EECF244321}">
+                <p14:modId xmlns:p14="http://schemas.microsoft.com/office/powerpoint/2010/main" val="936787039"/>
+              </p:ext>
+            </p:extLst>
+          </p:nvPr>
         </p:nvGraphicFramePr>
         <p:xfrm>
-          <a:off x="1322388" y="5691188"/>
-          <a:ext cx="1885950" cy="974725"/>
+          <a:off x="1053219" y="4833938"/>
+          <a:ext cx="1588381" cy="820931"/>
         </p:xfrm>
         <a:graphic>
           <a:graphicData uri="http://schemas.openxmlformats.org/presentationml/2006/ole">
@@ -17469,8 +17490,8 @@
                     </p:blipFill>
                     <p:spPr bwMode="auto">
                       <a:xfrm>
-                        <a:off x="1322388" y="5691188"/>
-                        <a:ext cx="1885950" cy="974725"/>
+                        <a:off x="1053219" y="4833938"/>
+                        <a:ext cx="1588381" cy="820931"/>
                       </a:xfrm>
                       <a:prstGeom prst="rect">
                         <a:avLst/>
@@ -17479,25 +17500,6 @@
                       <a:ln>
                         <a:noFill/>
                       </a:ln>
-                      <a:extLst>
-                        <a:ext uri="{909E8E84-426E-40DD-AFC4-6F175D3DCCD1}">
-                          <a14:hiddenFill xmlns:a14="http://schemas.microsoft.com/office/drawing/2010/main">
-                            <a:solidFill>
-                              <a:srgbClr val="FFFFFF"/>
-                            </a:solidFill>
-                          </a14:hiddenFill>
-                        </a:ext>
-                        <a:ext uri="{91240B29-F687-4F45-9708-019B960494DF}">
-                          <a14:hiddenLine xmlns:a14="http://schemas.microsoft.com/office/drawing/2010/main" w="9525">
-                            <a:solidFill>
-                              <a:srgbClr val="000000"/>
-                            </a:solidFill>
-                            <a:miter lim="800000"/>
-                            <a:headEnd/>
-                            <a:tailEnd/>
-                          </a14:hiddenLine>
-                        </a:ext>
-                      </a:extLst>
                     </p:spPr>
                   </p:pic>
                 </p:oleObj>
@@ -17518,11 +17520,17 @@
           <p:cNvGraphicFramePr>
             <a:graphicFrameLocks noChangeAspect="1"/>
           </p:cNvGraphicFramePr>
-          <p:nvPr/>
+          <p:nvPr>
+            <p:extLst>
+              <p:ext uri="{D42A27DB-BD31-4B8C-83A1-F6EECF244321}">
+                <p14:modId xmlns:p14="http://schemas.microsoft.com/office/powerpoint/2010/main" val="78614490"/>
+              </p:ext>
+            </p:extLst>
+          </p:nvPr>
         </p:nvGraphicFramePr>
         <p:xfrm>
-          <a:off x="1311275" y="2381250"/>
-          <a:ext cx="1728788" cy="974725"/>
+          <a:off x="1051631" y="2009775"/>
+          <a:ext cx="1456016" cy="820931"/>
         </p:xfrm>
         <a:graphic>
           <a:graphicData uri="http://schemas.openxmlformats.org/presentationml/2006/ole">
@@ -17564,8 +17572,8 @@
                     </p:blipFill>
                     <p:spPr bwMode="auto">
                       <a:xfrm>
-                        <a:off x="1311275" y="2381250"/>
-                        <a:ext cx="1728788" cy="974725"/>
+                        <a:off x="1051631" y="2009775"/>
+                        <a:ext cx="1456016" cy="820931"/>
                       </a:xfrm>
                       <a:prstGeom prst="rect">
                         <a:avLst/>
@@ -17574,25 +17582,6 @@
                       <a:ln>
                         <a:noFill/>
                       </a:ln>
-                      <a:extLst>
-                        <a:ext uri="{909E8E84-426E-40DD-AFC4-6F175D3DCCD1}">
-                          <a14:hiddenFill xmlns:a14="http://schemas.microsoft.com/office/drawing/2010/main">
-                            <a:solidFill>
-                              <a:srgbClr val="FFFFFF"/>
-                            </a:solidFill>
-                          </a14:hiddenFill>
-                        </a:ext>
-                        <a:ext uri="{91240B29-F687-4F45-9708-019B960494DF}">
-                          <a14:hiddenLine xmlns:a14="http://schemas.microsoft.com/office/drawing/2010/main" w="9525">
-                            <a:solidFill>
-                              <a:srgbClr val="000000"/>
-                            </a:solidFill>
-                            <a:miter lim="800000"/>
-                            <a:headEnd/>
-                            <a:tailEnd/>
-                          </a14:hiddenLine>
-                        </a:ext>
-                      </a:extLst>
                     </p:spPr>
                   </p:pic>
                 </p:oleObj>
@@ -17682,7 +17671,7 @@
               <a:buNone/>
             </a:pPr>
             <a:r>
-              <a:rPr lang="en-US" altLang="en-US" sz="2800"/>
+              <a:rPr lang="en-US" altLang="en-US" sz="2800" dirty="0"/>
               <a:t>About how many atoms (rough order of magnitude) are in a typical sample of material?</a:t>
             </a:r>
           </a:p>
@@ -17691,7 +17680,7 @@
               <a:buFontTx/>
               <a:buNone/>
             </a:pPr>
-            <a:endParaRPr lang="en-US" altLang="en-US" sz="2800"/>
+            <a:endParaRPr lang="en-US" altLang="en-US" sz="2800" dirty="0"/>
           </a:p>
           <a:p>
             <a:pPr>
@@ -17699,7 +17688,7 @@
               <a:buAutoNum type="alphaLcParenR"/>
             </a:pPr>
             <a:r>
-              <a:rPr lang="en-US" altLang="en-US" sz="2800"/>
+              <a:rPr lang="en-US" altLang="en-US" sz="2800" dirty="0"/>
               <a:t> </a:t>
             </a:r>
           </a:p>
@@ -17708,7 +17697,7 @@
               <a:buFontTx/>
               <a:buAutoNum type="alphaLcParenR"/>
             </a:pPr>
-            <a:endParaRPr lang="en-US" altLang="en-US" sz="2800"/>
+            <a:endParaRPr lang="en-US" altLang="en-US" sz="2800" dirty="0"/>
           </a:p>
           <a:p>
             <a:pPr>
@@ -17716,7 +17705,7 @@
               <a:buAutoNum type="alphaLcParenR"/>
             </a:pPr>
             <a:r>
-              <a:rPr lang="en-US" altLang="en-US" sz="2800"/>
+              <a:rPr lang="en-US" altLang="en-US" sz="2800" dirty="0"/>
               <a:t> </a:t>
             </a:r>
           </a:p>
@@ -17725,7 +17714,7 @@
               <a:buFontTx/>
               <a:buAutoNum type="alphaLcParenR"/>
             </a:pPr>
-            <a:endParaRPr lang="en-US" altLang="en-US" sz="2800"/>
+            <a:endParaRPr lang="en-US" altLang="en-US" sz="2800" dirty="0"/>
           </a:p>
           <a:p>
             <a:pPr>
@@ -17733,7 +17722,7 @@
               <a:buAutoNum type="alphaLcParenR"/>
             </a:pPr>
             <a:r>
-              <a:rPr lang="en-US" altLang="en-US" sz="2800"/>
+              <a:rPr lang="en-US" altLang="en-US" sz="2800" dirty="0"/>
               <a:t> </a:t>
             </a:r>
           </a:p>
@@ -17742,7 +17731,7 @@
               <a:buFontTx/>
               <a:buAutoNum type="alphaLcParenR"/>
             </a:pPr>
-            <a:endParaRPr lang="en-US" altLang="en-US" sz="2800"/>
+            <a:endParaRPr lang="en-US" altLang="en-US" sz="2800" dirty="0"/>
           </a:p>
           <a:p>
             <a:pPr>
@@ -17750,7 +17739,7 @@
               <a:buAutoNum type="alphaLcParenR"/>
             </a:pPr>
             <a:r>
-              <a:rPr lang="en-US" altLang="en-US" sz="2800"/>
+              <a:rPr lang="en-US" altLang="en-US" sz="2800" dirty="0"/>
               <a:t> </a:t>
             </a:r>
           </a:p>
@@ -17759,7 +17748,7 @@
               <a:buFontTx/>
               <a:buNone/>
             </a:pPr>
-            <a:endParaRPr lang="en-US" altLang="en-US" sz="2800"/>
+            <a:endParaRPr lang="en-US" altLang="en-US" sz="2800" dirty="0"/>
           </a:p>
         </p:txBody>
       </p:sp>
@@ -17924,11 +17913,17 @@
           <p:cNvGraphicFramePr>
             <a:graphicFrameLocks noChangeAspect="1"/>
           </p:cNvGraphicFramePr>
-          <p:nvPr/>
+          <p:nvPr>
+            <p:extLst>
+              <p:ext uri="{D42A27DB-BD31-4B8C-83A1-F6EECF244321}">
+                <p14:modId xmlns:p14="http://schemas.microsoft.com/office/powerpoint/2010/main" val="4197890397"/>
+              </p:ext>
+            </p:extLst>
+          </p:nvPr>
         </p:nvGraphicFramePr>
         <p:xfrm>
-          <a:off x="1568450" y="4935538"/>
-          <a:ext cx="1100138" cy="769937"/>
+          <a:off x="1105605" y="4588800"/>
+          <a:ext cx="652961" cy="456978"/>
         </p:xfrm>
         <a:graphic>
           <a:graphicData uri="http://schemas.openxmlformats.org/presentationml/2006/ole">
@@ -17970,8 +17965,8 @@
                     </p:blipFill>
                     <p:spPr bwMode="auto">
                       <a:xfrm>
-                        <a:off x="1568450" y="4935538"/>
-                        <a:ext cx="1100138" cy="769937"/>
+                        <a:off x="1105605" y="4588800"/>
+                        <a:ext cx="652961" cy="456978"/>
                       </a:xfrm>
                       <a:prstGeom prst="rect">
                         <a:avLst/>
@@ -17980,25 +17975,6 @@
                       <a:ln>
                         <a:noFill/>
                       </a:ln>
-                      <a:extLst>
-                        <a:ext uri="{909E8E84-426E-40DD-AFC4-6F175D3DCCD1}">
-                          <a14:hiddenFill xmlns:a14="http://schemas.microsoft.com/office/drawing/2010/main">
-                            <a:solidFill>
-                              <a:srgbClr val="FFFFFF"/>
-                            </a:solidFill>
-                          </a14:hiddenFill>
-                        </a:ext>
-                        <a:ext uri="{91240B29-F687-4F45-9708-019B960494DF}">
-                          <a14:hiddenLine xmlns:a14="http://schemas.microsoft.com/office/drawing/2010/main" w="9525">
-                            <a:solidFill>
-                              <a:srgbClr val="000000"/>
-                            </a:solidFill>
-                            <a:miter lim="800000"/>
-                            <a:headEnd/>
-                            <a:tailEnd/>
-                          </a14:hiddenLine>
-                        </a:ext>
-                      </a:extLst>
                     </p:spPr>
                   </p:pic>
                 </p:oleObj>
@@ -18019,11 +17995,17 @@
           <p:cNvGraphicFramePr>
             <a:graphicFrameLocks noChangeAspect="1"/>
           </p:cNvGraphicFramePr>
-          <p:nvPr/>
+          <p:nvPr>
+            <p:extLst>
+              <p:ext uri="{D42A27DB-BD31-4B8C-83A1-F6EECF244321}">
+                <p14:modId xmlns:p14="http://schemas.microsoft.com/office/powerpoint/2010/main" val="2549044267"/>
+              </p:ext>
+            </p:extLst>
+          </p:nvPr>
         </p:nvGraphicFramePr>
         <p:xfrm>
-          <a:off x="1609725" y="3919538"/>
-          <a:ext cx="942975" cy="808037"/>
+          <a:off x="1146880" y="3633442"/>
+          <a:ext cx="559681" cy="479592"/>
         </p:xfrm>
         <a:graphic>
           <a:graphicData uri="http://schemas.openxmlformats.org/presentationml/2006/ole">
@@ -18065,8 +18047,8 @@
                     </p:blipFill>
                     <p:spPr bwMode="auto">
                       <a:xfrm>
-                        <a:off x="1609725" y="3919538"/>
-                        <a:ext cx="942975" cy="808037"/>
+                        <a:off x="1146880" y="3633442"/>
+                        <a:ext cx="559681" cy="479592"/>
                       </a:xfrm>
                       <a:prstGeom prst="rect">
                         <a:avLst/>
@@ -18075,25 +18057,6 @@
                       <a:ln>
                         <a:noFill/>
                       </a:ln>
-                      <a:extLst>
-                        <a:ext uri="{909E8E84-426E-40DD-AFC4-6F175D3DCCD1}">
-                          <a14:hiddenFill xmlns:a14="http://schemas.microsoft.com/office/drawing/2010/main">
-                            <a:solidFill>
-                              <a:srgbClr val="FFFFFF"/>
-                            </a:solidFill>
-                          </a14:hiddenFill>
-                        </a:ext>
-                        <a:ext uri="{91240B29-F687-4F45-9708-019B960494DF}">
-                          <a14:hiddenLine xmlns:a14="http://schemas.microsoft.com/office/drawing/2010/main" w="9525">
-                            <a:solidFill>
-                              <a:srgbClr val="000000"/>
-                            </a:solidFill>
-                            <a:miter lim="800000"/>
-                            <a:headEnd/>
-                            <a:tailEnd/>
-                          </a14:hiddenLine>
-                        </a:ext>
-                      </a:extLst>
                     </p:spPr>
                   </p:pic>
                 </p:oleObj>
@@ -18114,11 +18077,17 @@
           <p:cNvGraphicFramePr>
             <a:graphicFrameLocks noChangeAspect="1"/>
           </p:cNvGraphicFramePr>
-          <p:nvPr/>
+          <p:nvPr>
+            <p:extLst>
+              <p:ext uri="{D42A27DB-BD31-4B8C-83A1-F6EECF244321}">
+                <p14:modId xmlns:p14="http://schemas.microsoft.com/office/powerpoint/2010/main" val="8036924"/>
+              </p:ext>
+            </p:extLst>
+          </p:nvPr>
         </p:nvGraphicFramePr>
         <p:xfrm>
-          <a:off x="1630363" y="5951538"/>
-          <a:ext cx="1152525" cy="804862"/>
+          <a:off x="1167518" y="5460949"/>
+          <a:ext cx="684055" cy="477708"/>
         </p:xfrm>
         <a:graphic>
           <a:graphicData uri="http://schemas.openxmlformats.org/presentationml/2006/ole">
@@ -18160,8 +18129,8 @@
                     </p:blipFill>
                     <p:spPr bwMode="auto">
                       <a:xfrm>
-                        <a:off x="1630363" y="5951538"/>
-                        <a:ext cx="1152525" cy="804862"/>
+                        <a:off x="1167518" y="5460949"/>
+                        <a:ext cx="684055" cy="477708"/>
                       </a:xfrm>
                       <a:prstGeom prst="rect">
                         <a:avLst/>
@@ -18170,25 +18139,6 @@
                       <a:ln>
                         <a:noFill/>
                       </a:ln>
-                      <a:extLst>
-                        <a:ext uri="{909E8E84-426E-40DD-AFC4-6F175D3DCCD1}">
-                          <a14:hiddenFill xmlns:a14="http://schemas.microsoft.com/office/drawing/2010/main">
-                            <a:solidFill>
-                              <a:srgbClr val="FFFFFF"/>
-                            </a:solidFill>
-                          </a14:hiddenFill>
-                        </a:ext>
-                        <a:ext uri="{91240B29-F687-4F45-9708-019B960494DF}">
-                          <a14:hiddenLine xmlns:a14="http://schemas.microsoft.com/office/drawing/2010/main" w="9525">
-                            <a:solidFill>
-                              <a:srgbClr val="000000"/>
-                            </a:solidFill>
-                            <a:miter lim="800000"/>
-                            <a:headEnd/>
-                            <a:tailEnd/>
-                          </a14:hiddenLine>
-                        </a:ext>
-                      </a:extLst>
                     </p:spPr>
                   </p:pic>
                 </p:oleObj>
@@ -18209,11 +18159,17 @@
           <p:cNvGraphicFramePr>
             <a:graphicFrameLocks noChangeAspect="1"/>
           </p:cNvGraphicFramePr>
-          <p:nvPr/>
+          <p:nvPr>
+            <p:extLst>
+              <p:ext uri="{D42A27DB-BD31-4B8C-83A1-F6EECF244321}">
+                <p14:modId xmlns:p14="http://schemas.microsoft.com/office/powerpoint/2010/main" val="1765648947"/>
+              </p:ext>
+            </p:extLst>
+          </p:nvPr>
         </p:nvGraphicFramePr>
         <p:xfrm>
-          <a:off x="1630363" y="2946400"/>
-          <a:ext cx="942975" cy="773113"/>
+          <a:off x="1167518" y="2860600"/>
+          <a:ext cx="559681" cy="458863"/>
         </p:xfrm>
         <a:graphic>
           <a:graphicData uri="http://schemas.openxmlformats.org/presentationml/2006/ole">
@@ -18255,8 +18211,8 @@
                     </p:blipFill>
                     <p:spPr bwMode="auto">
                       <a:xfrm>
-                        <a:off x="1630363" y="2946400"/>
-                        <a:ext cx="942975" cy="773113"/>
+                        <a:off x="1167518" y="2860600"/>
+                        <a:ext cx="559681" cy="458863"/>
                       </a:xfrm>
                       <a:prstGeom prst="rect">
                         <a:avLst/>
@@ -18265,25 +18221,6 @@
                       <a:ln>
                         <a:noFill/>
                       </a:ln>
-                      <a:extLst>
-                        <a:ext uri="{909E8E84-426E-40DD-AFC4-6F175D3DCCD1}">
-                          <a14:hiddenFill xmlns:a14="http://schemas.microsoft.com/office/drawing/2010/main">
-                            <a:solidFill>
-                              <a:srgbClr val="FFFFFF"/>
-                            </a:solidFill>
-                          </a14:hiddenFill>
-                        </a:ext>
-                        <a:ext uri="{91240B29-F687-4F45-9708-019B960494DF}">
-                          <a14:hiddenLine xmlns:a14="http://schemas.microsoft.com/office/drawing/2010/main" w="9525">
-                            <a:solidFill>
-                              <a:srgbClr val="000000"/>
-                            </a:solidFill>
-                            <a:miter lim="800000"/>
-                            <a:headEnd/>
-                            <a:tailEnd/>
-                          </a14:hiddenLine>
-                        </a:ext>
-                      </a:extLst>
                     </p:spPr>
                   </p:pic>
                 </p:oleObj>

</xml_diff>